<commit_message>
Add team members to README, report, proposal and presentation
</commit_message>
<xml_diff>
--- a/Presentation/Credit Card Fraud Detection - Presentation.pptx
+++ b/Presentation/Credit Card Fraud Detection - Presentation.pptx
@@ -2727,8 +2727,8 @@
         </p:nvSpPr>
         <p:spPr>
           <a:xfrm>
-            <a:off x="822960" y="4251960"/>
-            <a:ext cx="5943600" cy="1554480"/>
+            <a:off x="822960" y="4206240"/>
+            <a:ext cx="6400800" cy="1645920"/>
           </a:xfrm>
           <a:prstGeom prst="rect">
             <a:avLst/>
@@ -2744,56 +2744,70 @@
               <a:buNone/>
             </a:pPr>
             <a:r>
-              <a:rPr lang="en-US" sz="1900" b="1" dirty="0">
+              <a:rPr lang="en-US" sz="1500" b="1" dirty="0">
                 <a:solidFill>
                   <a:srgbClr val="FFFFFF"/>
                 </a:solidFill>
               </a:rPr>
-              <a:t>Lakshay</a:t>
+              <a:t>Akshita Modi  ·  AP24110010386</a:t>
             </a:r>
-            <a:endParaRPr lang="en-US" sz="1900" dirty="0"/>
+            <a:endParaRPr lang="en-US" sz="1500" dirty="0"/>
           </a:p>
           <a:p>
             <a:pPr indent="0" marL="0">
               <a:buNone/>
             </a:pPr>
             <a:r>
-              <a:rPr lang="en-US" sz="1500" dirty="0">
+              <a:rPr lang="en-US" sz="1500" b="1" dirty="0">
                 <a:solidFill>
                   <a:srgbClr val="FFFFFF"/>
                 </a:solidFill>
               </a:rPr>
-              <a:t>Roll No: AP24110010677</a:t>
+              <a:t>Lakshay  ·  AP24110010677</a:t>
             </a:r>
-            <a:endParaRPr lang="en-US" sz="1900" dirty="0"/>
+            <a:endParaRPr lang="en-US" sz="1500" dirty="0"/>
           </a:p>
           <a:p>
             <a:pPr indent="0" marL="0">
               <a:buNone/>
             </a:pPr>
             <a:r>
-              <a:rPr lang="en-US" sz="1500" dirty="0">
+              <a:rPr lang="en-US" sz="1500" b="1" dirty="0">
                 <a:solidFill>
                   <a:srgbClr val="FFFFFF"/>
                 </a:solidFill>
               </a:rPr>
-              <a:t>B.Tech Computer Science and Engineering</a:t>
+              <a:t>Mohana Krishna Reddy Pittu  ·  AP24110011262</a:t>
             </a:r>
-            <a:endParaRPr lang="en-US" sz="1900" dirty="0"/>
+            <a:endParaRPr lang="en-US" sz="1500" dirty="0"/>
           </a:p>
           <a:p>
             <a:pPr indent="0" marL="0">
               <a:buNone/>
             </a:pPr>
             <a:r>
-              <a:rPr lang="en-US" sz="1500" dirty="0">
+              <a:rPr lang="en-US" sz="1500" b="1" dirty="0">
                 <a:solidFill>
                   <a:srgbClr val="FFFFFF"/>
                 </a:solidFill>
               </a:rPr>
-              <a:t>SRM University – AP</a:t>
+              <a:t>Nadimpally Dheva Harshit  ·  AP24110011553</a:t>
             </a:r>
-            <a:endParaRPr lang="en-US" sz="1900" dirty="0"/>
+            <a:endParaRPr lang="en-US" sz="1500" dirty="0"/>
+          </a:p>
+          <a:p>
+            <a:pPr indent="0" marL="0">
+              <a:buNone/>
+            </a:pPr>
+            <a:r>
+              <a:rPr lang="en-US" sz="1300" dirty="0">
+                <a:solidFill>
+                  <a:srgbClr val="CADCFC"/>
+                </a:solidFill>
+              </a:rPr>
+              <a:t>B.Tech Computer Science and Engineering  ·  SRM University – AP</a:t>
+            </a:r>
+            <a:endParaRPr lang="en-US" sz="1500" dirty="0"/>
           </a:p>
         </p:txBody>
       </p:sp>
@@ -14663,7 +14677,22 @@
                   <a:srgbClr val="FFFFFF"/>
                 </a:solidFill>
               </a:rPr>
-              <a:t>Lakshay · AP24110010677 · B.Tech CSE · SRM University – AP
+              <a:t>Akshita Modi · Lakshay · Mohana Krishna Reddy Pittu · Nadimpally Dheva Harshit
+</a:t>
+            </a:r>
+            <a:endParaRPr lang="en-US" sz="1400" dirty="0"/>
+          </a:p>
+          <a:p>
+            <a:pPr indent="0" marL="0">
+              <a:buNone/>
+            </a:pPr>
+            <a:r>
+              <a:rPr lang="en-US" sz="1300" dirty="0">
+                <a:solidFill>
+                  <a:srgbClr val="CADCFC"/>
+                </a:solidFill>
+              </a:rPr>
+              <a:t>B.Tech CSE · SRM University – AP
 </a:t>
             </a:r>
             <a:endParaRPr lang="en-US" sz="1400" dirty="0"/>

</xml_diff>